<commit_message>
fix: refresh db chapter 3 exercise answers
</commit_message>
<xml_diff>
--- a/data/DB시스템/3장_연습문제_문제_정답.pptx
+++ b/data/DB시스템/3장_연습문제_문제_정답.pptx
@@ -6670,7 +6670,7 @@
                 <a:ea typeface="Calibri" pitchFamily="34" charset="-122"/>
                 <a:cs typeface="Calibri" pitchFamily="34" charset="-120"/>
               </a:rPr>
-              <a:t>① 사상 기능  ② 정의 기능  ③ 조작 기능  ④ 제어 기능</a:t>
+              <a:t>① 사상 기능</a:t>
             </a:r>
             <a:endParaRPr lang="en-US" sz="1100" dirty="0"/>
           </a:p>
@@ -6684,7 +6684,144 @@
         </p:nvSpPr>
         <p:spPr>
           <a:xfrm>
-            <a:off x="548640" y="1545336"/>
+            <a:off x="502920" y="1472184"/>
+            <a:ext cx="8138160" cy="256032"/>
+          </a:xfrm>
+          <a:prstGeom prst="rect">
+            <a:avLst/>
+          </a:prstGeom>
+          <a:solidFill>
+            <a:srgbClr val="FEE2E2"/>
+          </a:solidFill>
+          <a:ln/>
+        </p:spPr>
+      </p:sp>
+      <p:sp>
+        <p:nvSpPr>
+          <p:cNvPr id="10" name="Text 8"/>
+          <p:cNvSpPr/>
+          <p:nvPr/>
+        </p:nvSpPr>
+        <p:spPr>
+          <a:xfrm>
+            <a:off x="640080" y="1472184"/>
+            <a:ext cx="7863840" cy="256032"/>
+          </a:xfrm>
+          <a:prstGeom prst="rect">
+            <a:avLst/>
+          </a:prstGeom>
+          <a:noFill/>
+          <a:ln/>
+        </p:spPr>
+        <p:txBody>
+          <a:bodyPr wrap="square" rtlCol="0" anchor="ctr"/>
+          <a:lstStyle/>
+          <a:p>
+            <a:pPr indent="0" marL="0">
+              <a:buNone/>
+            </a:pPr>
+            <a:r>
+              <a:rPr lang="en-US" sz="1100" b="1" dirty="0">
+                <a:solidFill>
+                  <a:srgbClr val="EF4444"/>
+                </a:solidFill>
+                <a:latin typeface="Calibri" pitchFamily="34" charset="0"/>
+                <a:ea typeface="Calibri" pitchFamily="34" charset="-122"/>
+                <a:cs typeface="Calibri" pitchFamily="34" charset="-120"/>
+              </a:rPr>
+              <a:t>② 정의 기능</a:t>
+            </a:r>
+            <a:endParaRPr lang="en-US" sz="1100" dirty="0"/>
+          </a:p>
+        </p:txBody>
+      </p:sp>
+      <p:sp>
+        <p:nvSpPr>
+          <p:cNvPr id="11" name="Text 9"/>
+          <p:cNvSpPr/>
+          <p:nvPr/>
+        </p:nvSpPr>
+        <p:spPr>
+          <a:xfrm>
+            <a:off x="640080" y="1728216"/>
+            <a:ext cx="7863840" cy="256032"/>
+          </a:xfrm>
+          <a:prstGeom prst="rect">
+            <a:avLst/>
+          </a:prstGeom>
+          <a:noFill/>
+          <a:ln/>
+        </p:spPr>
+        <p:txBody>
+          <a:bodyPr wrap="square" rtlCol="0" anchor="ctr"/>
+          <a:lstStyle/>
+          <a:p>
+            <a:pPr indent="0" marL="0">
+              <a:buNone/>
+            </a:pPr>
+            <a:r>
+              <a:rPr lang="en-US" sz="1100" dirty="0">
+                <a:solidFill>
+                  <a:srgbClr val="64748B"/>
+                </a:solidFill>
+                <a:latin typeface="Calibri" pitchFamily="34" charset="0"/>
+                <a:ea typeface="Calibri" pitchFamily="34" charset="-122"/>
+                <a:cs typeface="Calibri" pitchFamily="34" charset="-120"/>
+              </a:rPr>
+              <a:t>③ 조작 기능</a:t>
+            </a:r>
+            <a:endParaRPr lang="en-US" sz="1100" dirty="0"/>
+          </a:p>
+        </p:txBody>
+      </p:sp>
+      <p:sp>
+        <p:nvSpPr>
+          <p:cNvPr id="12" name="Text 10"/>
+          <p:cNvSpPr/>
+          <p:nvPr/>
+        </p:nvSpPr>
+        <p:spPr>
+          <a:xfrm>
+            <a:off x="640080" y="1984248"/>
+            <a:ext cx="7863840" cy="256032"/>
+          </a:xfrm>
+          <a:prstGeom prst="rect">
+            <a:avLst/>
+          </a:prstGeom>
+          <a:noFill/>
+          <a:ln/>
+        </p:spPr>
+        <p:txBody>
+          <a:bodyPr wrap="square" rtlCol="0" anchor="ctr"/>
+          <a:lstStyle/>
+          <a:p>
+            <a:pPr indent="0" marL="0">
+              <a:buNone/>
+            </a:pPr>
+            <a:r>
+              <a:rPr lang="en-US" sz="1100" dirty="0">
+                <a:solidFill>
+                  <a:srgbClr val="64748B"/>
+                </a:solidFill>
+                <a:latin typeface="Calibri" pitchFamily="34" charset="0"/>
+                <a:ea typeface="Calibri" pitchFamily="34" charset="-122"/>
+                <a:cs typeface="Calibri" pitchFamily="34" charset="-120"/>
+              </a:rPr>
+              <a:t>④ 제어 기능</a:t>
+            </a:r>
+            <a:endParaRPr lang="en-US" sz="1100" dirty="0"/>
+          </a:p>
+        </p:txBody>
+      </p:sp>
+      <p:sp>
+        <p:nvSpPr>
+          <p:cNvPr id="13" name="Shape 11"/>
+          <p:cNvSpPr/>
+          <p:nvPr/>
+        </p:nvSpPr>
+        <p:spPr>
+          <a:xfrm>
+            <a:off x="548640" y="2313432"/>
             <a:ext cx="8046720" cy="10973"/>
           </a:xfrm>
           <a:prstGeom prst="rect">
@@ -6698,14 +6835,14 @@
       </p:sp>
       <p:sp>
         <p:nvSpPr>
-          <p:cNvPr id="10" name="Shape 8"/>
-          <p:cNvSpPr/>
-          <p:nvPr/>
-        </p:nvSpPr>
-        <p:spPr>
-          <a:xfrm>
-            <a:off x="548640" y="1655064"/>
-            <a:ext cx="8046720" cy="3054096"/>
+          <p:cNvPr id="14" name="Shape 12"/>
+          <p:cNvSpPr/>
+          <p:nvPr/>
+        </p:nvSpPr>
+        <p:spPr>
+          <a:xfrm>
+            <a:off x="548640" y="2423160"/>
+            <a:ext cx="8046720" cy="2286000"/>
           </a:xfrm>
           <a:prstGeom prst="rect">
             <a:avLst/>
@@ -6725,14 +6862,14 @@
       </p:sp>
       <p:sp>
         <p:nvSpPr>
-          <p:cNvPr id="11" name="Shape 9"/>
-          <p:cNvSpPr/>
-          <p:nvPr/>
-        </p:nvSpPr>
-        <p:spPr>
-          <a:xfrm>
-            <a:off x="548640" y="1655064"/>
-            <a:ext cx="54864" cy="3054096"/>
+          <p:cNvPr id="15" name="Shape 13"/>
+          <p:cNvSpPr/>
+          <p:nvPr/>
+        </p:nvSpPr>
+        <p:spPr>
+          <a:xfrm>
+            <a:off x="548640" y="2423160"/>
+            <a:ext cx="54864" cy="2286000"/>
           </a:xfrm>
           <a:prstGeom prst="rect">
             <a:avLst/>
@@ -6745,13 +6882,13 @@
       </p:sp>
       <p:sp>
         <p:nvSpPr>
-          <p:cNvPr id="12" name="Text 10"/>
-          <p:cNvSpPr/>
-          <p:nvPr/>
-        </p:nvSpPr>
-        <p:spPr>
-          <a:xfrm>
-            <a:off x="777240" y="1700784"/>
+          <p:cNvPr id="16" name="Text 14"/>
+          <p:cNvSpPr/>
+          <p:nvPr/>
+        </p:nvSpPr>
+        <p:spPr>
+          <a:xfrm>
+            <a:off x="777240" y="2468880"/>
             <a:ext cx="914400" cy="228600"/>
           </a:xfrm>
           <a:prstGeom prst="rect">
@@ -6784,14 +6921,14 @@
       </p:sp>
       <p:sp>
         <p:nvSpPr>
-          <p:cNvPr id="13" name="Text 11"/>
-          <p:cNvSpPr/>
-          <p:nvPr/>
-        </p:nvSpPr>
-        <p:spPr>
-          <a:xfrm>
-            <a:off x="777240" y="1929384"/>
-            <a:ext cx="7589520" cy="2688336"/>
+          <p:cNvPr id="17" name="Text 15"/>
+          <p:cNvSpPr/>
+          <p:nvPr/>
+        </p:nvSpPr>
+        <p:spPr>
+          <a:xfrm>
+            <a:off x="777240" y="2697480"/>
+            <a:ext cx="7589520" cy="1920240"/>
           </a:xfrm>
           <a:prstGeom prst="rect">
             <a:avLst/>
@@ -6826,7 +6963,7 @@
       </p:sp>
       <p:sp>
         <p:nvSpPr>
-          <p:cNvPr id="14" name="Text 12"/>
+          <p:cNvPr id="18" name="Text 16"/>
           <p:cNvSpPr/>
           <p:nvPr/>
         </p:nvSpPr>
@@ -12743,7 +12880,7 @@
                 <a:ea typeface="Calibri" pitchFamily="34" charset="-122"/>
                 <a:cs typeface="Calibri" pitchFamily="34" charset="-120"/>
               </a:rPr>
-              <a:t>① 데이터 정의어(DDL)  ② 데이터 조작어(DML)</a:t>
+              <a:t>① 데이터 정의어(DDL)</a:t>
             </a:r>
             <a:endParaRPr lang="en-US" sz="1100" dirty="0"/>
           </a:p>
@@ -12751,7 +12888,27 @@
       </p:sp>
       <p:sp>
         <p:nvSpPr>
-          <p:cNvPr id="9" name="Text 7"/>
+          <p:cNvPr id="9" name="Shape 7"/>
+          <p:cNvSpPr/>
+          <p:nvPr/>
+        </p:nvSpPr>
+        <p:spPr>
+          <a:xfrm>
+            <a:off x="502920" y="1472184"/>
+            <a:ext cx="8138160" cy="256032"/>
+          </a:xfrm>
+          <a:prstGeom prst="rect">
+            <a:avLst/>
+          </a:prstGeom>
+          <a:solidFill>
+            <a:srgbClr val="FEE2E2"/>
+          </a:solidFill>
+          <a:ln/>
+        </p:spPr>
+      </p:sp>
+      <p:sp>
+        <p:nvSpPr>
+          <p:cNvPr id="10" name="Text 8"/>
           <p:cNvSpPr/>
           <p:nvPr/>
         </p:nvSpPr>
@@ -12774,15 +12931,15 @@
               <a:buNone/>
             </a:pPr>
             <a:r>
-              <a:rPr lang="en-US" sz="1100" dirty="0">
-                <a:solidFill>
-                  <a:srgbClr val="64748B"/>
+              <a:rPr lang="en-US" sz="1100" b="1" dirty="0">
+                <a:solidFill>
+                  <a:srgbClr val="EF4444"/>
                 </a:solidFill>
                 <a:latin typeface="Calibri" pitchFamily="34" charset="0"/>
                 <a:ea typeface="Calibri" pitchFamily="34" charset="-122"/>
                 <a:cs typeface="Calibri" pitchFamily="34" charset="-120"/>
               </a:rPr>
-              <a:t>③ 데이터 제어어(DCL)  ④ 데이터 요청어(DRL)</a:t>
+              <a:t>② 데이터 조작어(DML)</a:t>
             </a:r>
             <a:endParaRPr lang="en-US" sz="1100" dirty="0"/>
           </a:p>
@@ -12790,13 +12947,91 @@
       </p:sp>
       <p:sp>
         <p:nvSpPr>
-          <p:cNvPr id="10" name="Shape 8"/>
-          <p:cNvSpPr/>
-          <p:nvPr/>
-        </p:nvSpPr>
-        <p:spPr>
-          <a:xfrm>
-            <a:off x="548640" y="1801368"/>
+          <p:cNvPr id="11" name="Text 9"/>
+          <p:cNvSpPr/>
+          <p:nvPr/>
+        </p:nvSpPr>
+        <p:spPr>
+          <a:xfrm>
+            <a:off x="640080" y="1728216"/>
+            <a:ext cx="7863840" cy="256032"/>
+          </a:xfrm>
+          <a:prstGeom prst="rect">
+            <a:avLst/>
+          </a:prstGeom>
+          <a:noFill/>
+          <a:ln/>
+        </p:spPr>
+        <p:txBody>
+          <a:bodyPr wrap="square" rtlCol="0" anchor="ctr"/>
+          <a:lstStyle/>
+          <a:p>
+            <a:pPr indent="0" marL="0">
+              <a:buNone/>
+            </a:pPr>
+            <a:r>
+              <a:rPr lang="en-US" sz="1100" dirty="0">
+                <a:solidFill>
+                  <a:srgbClr val="64748B"/>
+                </a:solidFill>
+                <a:latin typeface="Calibri" pitchFamily="34" charset="0"/>
+                <a:ea typeface="Calibri" pitchFamily="34" charset="-122"/>
+                <a:cs typeface="Calibri" pitchFamily="34" charset="-120"/>
+              </a:rPr>
+              <a:t>③ 데이터 제어어(DCL)</a:t>
+            </a:r>
+            <a:endParaRPr lang="en-US" sz="1100" dirty="0"/>
+          </a:p>
+        </p:txBody>
+      </p:sp>
+      <p:sp>
+        <p:nvSpPr>
+          <p:cNvPr id="12" name="Text 10"/>
+          <p:cNvSpPr/>
+          <p:nvPr/>
+        </p:nvSpPr>
+        <p:spPr>
+          <a:xfrm>
+            <a:off x="640080" y="1984248"/>
+            <a:ext cx="7863840" cy="256032"/>
+          </a:xfrm>
+          <a:prstGeom prst="rect">
+            <a:avLst/>
+          </a:prstGeom>
+          <a:noFill/>
+          <a:ln/>
+        </p:spPr>
+        <p:txBody>
+          <a:bodyPr wrap="square" rtlCol="0" anchor="ctr"/>
+          <a:lstStyle/>
+          <a:p>
+            <a:pPr indent="0" marL="0">
+              <a:buNone/>
+            </a:pPr>
+            <a:r>
+              <a:rPr lang="en-US" sz="1100" dirty="0">
+                <a:solidFill>
+                  <a:srgbClr val="64748B"/>
+                </a:solidFill>
+                <a:latin typeface="Calibri" pitchFamily="34" charset="0"/>
+                <a:ea typeface="Calibri" pitchFamily="34" charset="-122"/>
+                <a:cs typeface="Calibri" pitchFamily="34" charset="-120"/>
+              </a:rPr>
+              <a:t>④ 데이터 요청어(DRL)</a:t>
+            </a:r>
+            <a:endParaRPr lang="en-US" sz="1100" dirty="0"/>
+          </a:p>
+        </p:txBody>
+      </p:sp>
+      <p:sp>
+        <p:nvSpPr>
+          <p:cNvPr id="13" name="Shape 11"/>
+          <p:cNvSpPr/>
+          <p:nvPr/>
+        </p:nvSpPr>
+        <p:spPr>
+          <a:xfrm>
+            <a:off x="548640" y="2313432"/>
             <a:ext cx="8046720" cy="10973"/>
           </a:xfrm>
           <a:prstGeom prst="rect">
@@ -12810,14 +13045,14 @@
       </p:sp>
       <p:sp>
         <p:nvSpPr>
-          <p:cNvPr id="11" name="Shape 9"/>
-          <p:cNvSpPr/>
-          <p:nvPr/>
-        </p:nvSpPr>
-        <p:spPr>
-          <a:xfrm>
-            <a:off x="548640" y="1911096"/>
-            <a:ext cx="8046720" cy="2798064"/>
+          <p:cNvPr id="14" name="Shape 12"/>
+          <p:cNvSpPr/>
+          <p:nvPr/>
+        </p:nvSpPr>
+        <p:spPr>
+          <a:xfrm>
+            <a:off x="548640" y="2423160"/>
+            <a:ext cx="8046720" cy="2286000"/>
           </a:xfrm>
           <a:prstGeom prst="rect">
             <a:avLst/>
@@ -12837,14 +13072,14 @@
       </p:sp>
       <p:sp>
         <p:nvSpPr>
-          <p:cNvPr id="12" name="Shape 10"/>
-          <p:cNvSpPr/>
-          <p:nvPr/>
-        </p:nvSpPr>
-        <p:spPr>
-          <a:xfrm>
-            <a:off x="548640" y="1911096"/>
-            <a:ext cx="54864" cy="2798064"/>
+          <p:cNvPr id="15" name="Shape 13"/>
+          <p:cNvSpPr/>
+          <p:nvPr/>
+        </p:nvSpPr>
+        <p:spPr>
+          <a:xfrm>
+            <a:off x="548640" y="2423160"/>
+            <a:ext cx="54864" cy="2286000"/>
           </a:xfrm>
           <a:prstGeom prst="rect">
             <a:avLst/>
@@ -12857,13 +13092,13 @@
       </p:sp>
       <p:sp>
         <p:nvSpPr>
-          <p:cNvPr id="13" name="Text 11"/>
-          <p:cNvSpPr/>
-          <p:nvPr/>
-        </p:nvSpPr>
-        <p:spPr>
-          <a:xfrm>
-            <a:off x="777240" y="1956816"/>
+          <p:cNvPr id="16" name="Text 14"/>
+          <p:cNvSpPr/>
+          <p:nvPr/>
+        </p:nvSpPr>
+        <p:spPr>
+          <a:xfrm>
+            <a:off x="777240" y="2468880"/>
             <a:ext cx="914400" cy="228600"/>
           </a:xfrm>
           <a:prstGeom prst="rect">
@@ -12896,14 +13131,14 @@
       </p:sp>
       <p:sp>
         <p:nvSpPr>
-          <p:cNvPr id="14" name="Text 12"/>
-          <p:cNvSpPr/>
-          <p:nvPr/>
-        </p:nvSpPr>
-        <p:spPr>
-          <a:xfrm>
-            <a:off x="777240" y="2185416"/>
-            <a:ext cx="7589520" cy="2432304"/>
+          <p:cNvPr id="17" name="Text 15"/>
+          <p:cNvSpPr/>
+          <p:nvPr/>
+        </p:nvSpPr>
+        <p:spPr>
+          <a:xfrm>
+            <a:off x="777240" y="2697480"/>
+            <a:ext cx="7589520" cy="1920240"/>
           </a:xfrm>
           <a:prstGeom prst="rect">
             <a:avLst/>
@@ -12938,7 +13173,7 @@
       </p:sp>
       <p:sp>
         <p:nvSpPr>
-          <p:cNvPr id="15" name="Text 13"/>
+          <p:cNvPr id="18" name="Text 16"/>
           <p:cNvSpPr/>
           <p:nvPr/>
         </p:nvSpPr>
@@ -14555,7 +14790,7 @@
                 <a:ea typeface="Calibri" pitchFamily="34" charset="-122"/>
                 <a:cs typeface="Calibri" pitchFamily="34" charset="-120"/>
               </a:rPr>
-              <a:t>① 데이터 정의어  ② 데이터 조작어  ③ 데이터 제어어  ④ 데이터 관리어</a:t>
+              <a:t>① 데이터 정의어</a:t>
             </a:r>
             <a:endParaRPr lang="en-US" sz="1100" dirty="0"/>
           </a:p>
@@ -14563,13 +14798,130 @@
       </p:sp>
       <p:sp>
         <p:nvSpPr>
-          <p:cNvPr id="10" name="Shape 8"/>
-          <p:cNvSpPr/>
-          <p:nvPr/>
-        </p:nvSpPr>
-        <p:spPr>
-          <a:xfrm>
-            <a:off x="548640" y="1399032"/>
+          <p:cNvPr id="10" name="Text 8"/>
+          <p:cNvSpPr/>
+          <p:nvPr/>
+        </p:nvSpPr>
+        <p:spPr>
+          <a:xfrm>
+            <a:off x="640080" y="1325880"/>
+            <a:ext cx="7863840" cy="256032"/>
+          </a:xfrm>
+          <a:prstGeom prst="rect">
+            <a:avLst/>
+          </a:prstGeom>
+          <a:noFill/>
+          <a:ln/>
+        </p:spPr>
+        <p:txBody>
+          <a:bodyPr wrap="square" rtlCol="0" anchor="ctr"/>
+          <a:lstStyle/>
+          <a:p>
+            <a:pPr indent="0" marL="0">
+              <a:buNone/>
+            </a:pPr>
+            <a:r>
+              <a:rPr lang="en-US" sz="1100" dirty="0">
+                <a:solidFill>
+                  <a:srgbClr val="64748B"/>
+                </a:solidFill>
+                <a:latin typeface="Calibri" pitchFamily="34" charset="0"/>
+                <a:ea typeface="Calibri" pitchFamily="34" charset="-122"/>
+                <a:cs typeface="Calibri" pitchFamily="34" charset="-120"/>
+              </a:rPr>
+              <a:t>② 데이터 조작어</a:t>
+            </a:r>
+            <a:endParaRPr lang="en-US" sz="1100" dirty="0"/>
+          </a:p>
+        </p:txBody>
+      </p:sp>
+      <p:sp>
+        <p:nvSpPr>
+          <p:cNvPr id="11" name="Text 9"/>
+          <p:cNvSpPr/>
+          <p:nvPr/>
+        </p:nvSpPr>
+        <p:spPr>
+          <a:xfrm>
+            <a:off x="640080" y="1581912"/>
+            <a:ext cx="7863840" cy="256032"/>
+          </a:xfrm>
+          <a:prstGeom prst="rect">
+            <a:avLst/>
+          </a:prstGeom>
+          <a:noFill/>
+          <a:ln/>
+        </p:spPr>
+        <p:txBody>
+          <a:bodyPr wrap="square" rtlCol="0" anchor="ctr"/>
+          <a:lstStyle/>
+          <a:p>
+            <a:pPr indent="0" marL="0">
+              <a:buNone/>
+            </a:pPr>
+            <a:r>
+              <a:rPr lang="en-US" sz="1100" dirty="0">
+                <a:solidFill>
+                  <a:srgbClr val="64748B"/>
+                </a:solidFill>
+                <a:latin typeface="Calibri" pitchFamily="34" charset="0"/>
+                <a:ea typeface="Calibri" pitchFamily="34" charset="-122"/>
+                <a:cs typeface="Calibri" pitchFamily="34" charset="-120"/>
+              </a:rPr>
+              <a:t>③ 데이터 제어어</a:t>
+            </a:r>
+            <a:endParaRPr lang="en-US" sz="1100" dirty="0"/>
+          </a:p>
+        </p:txBody>
+      </p:sp>
+      <p:sp>
+        <p:nvSpPr>
+          <p:cNvPr id="12" name="Text 10"/>
+          <p:cNvSpPr/>
+          <p:nvPr/>
+        </p:nvSpPr>
+        <p:spPr>
+          <a:xfrm>
+            <a:off x="640080" y="1837944"/>
+            <a:ext cx="7863840" cy="256032"/>
+          </a:xfrm>
+          <a:prstGeom prst="rect">
+            <a:avLst/>
+          </a:prstGeom>
+          <a:noFill/>
+          <a:ln/>
+        </p:spPr>
+        <p:txBody>
+          <a:bodyPr wrap="square" rtlCol="0" anchor="ctr"/>
+          <a:lstStyle/>
+          <a:p>
+            <a:pPr indent="0" marL="0">
+              <a:buNone/>
+            </a:pPr>
+            <a:r>
+              <a:rPr lang="en-US" sz="1100" dirty="0">
+                <a:solidFill>
+                  <a:srgbClr val="64748B"/>
+                </a:solidFill>
+                <a:latin typeface="Calibri" pitchFamily="34" charset="0"/>
+                <a:ea typeface="Calibri" pitchFamily="34" charset="-122"/>
+                <a:cs typeface="Calibri" pitchFamily="34" charset="-120"/>
+              </a:rPr>
+              <a:t>④ 데이터 관리어</a:t>
+            </a:r>
+            <a:endParaRPr lang="en-US" sz="1100" dirty="0"/>
+          </a:p>
+        </p:txBody>
+      </p:sp>
+      <p:sp>
+        <p:nvSpPr>
+          <p:cNvPr id="13" name="Shape 11"/>
+          <p:cNvSpPr/>
+          <p:nvPr/>
+        </p:nvSpPr>
+        <p:spPr>
+          <a:xfrm>
+            <a:off x="548640" y="2167128"/>
             <a:ext cx="8046720" cy="10973"/>
           </a:xfrm>
           <a:prstGeom prst="rect">
@@ -14583,14 +14935,14 @@
       </p:sp>
       <p:sp>
         <p:nvSpPr>
-          <p:cNvPr id="11" name="Shape 9"/>
-          <p:cNvSpPr/>
-          <p:nvPr/>
-        </p:nvSpPr>
-        <p:spPr>
-          <a:xfrm>
-            <a:off x="548640" y="1508760"/>
-            <a:ext cx="8046720" cy="3200400"/>
+          <p:cNvPr id="14" name="Shape 12"/>
+          <p:cNvSpPr/>
+          <p:nvPr/>
+        </p:nvSpPr>
+        <p:spPr>
+          <a:xfrm>
+            <a:off x="548640" y="2276856"/>
+            <a:ext cx="8046720" cy="2432304"/>
           </a:xfrm>
           <a:prstGeom prst="rect">
             <a:avLst/>
@@ -14610,14 +14962,14 @@
       </p:sp>
       <p:sp>
         <p:nvSpPr>
-          <p:cNvPr id="12" name="Shape 10"/>
-          <p:cNvSpPr/>
-          <p:nvPr/>
-        </p:nvSpPr>
-        <p:spPr>
-          <a:xfrm>
-            <a:off x="548640" y="1508760"/>
-            <a:ext cx="54864" cy="3200400"/>
+          <p:cNvPr id="15" name="Shape 13"/>
+          <p:cNvSpPr/>
+          <p:nvPr/>
+        </p:nvSpPr>
+        <p:spPr>
+          <a:xfrm>
+            <a:off x="548640" y="2276856"/>
+            <a:ext cx="54864" cy="2432304"/>
           </a:xfrm>
           <a:prstGeom prst="rect">
             <a:avLst/>
@@ -14630,13 +14982,13 @@
       </p:sp>
       <p:sp>
         <p:nvSpPr>
-          <p:cNvPr id="13" name="Text 11"/>
-          <p:cNvSpPr/>
-          <p:nvPr/>
-        </p:nvSpPr>
-        <p:spPr>
-          <a:xfrm>
-            <a:off x="777240" y="1554480"/>
+          <p:cNvPr id="16" name="Text 14"/>
+          <p:cNvSpPr/>
+          <p:nvPr/>
+        </p:nvSpPr>
+        <p:spPr>
+          <a:xfrm>
+            <a:off x="777240" y="2322576"/>
             <a:ext cx="914400" cy="228600"/>
           </a:xfrm>
           <a:prstGeom prst="rect">
@@ -14669,14 +15021,14 @@
       </p:sp>
       <p:sp>
         <p:nvSpPr>
-          <p:cNvPr id="14" name="Text 12"/>
-          <p:cNvSpPr/>
-          <p:nvPr/>
-        </p:nvSpPr>
-        <p:spPr>
-          <a:xfrm>
-            <a:off x="777240" y="1783080"/>
-            <a:ext cx="7589520" cy="2834640"/>
+          <p:cNvPr id="17" name="Text 15"/>
+          <p:cNvSpPr/>
+          <p:nvPr/>
+        </p:nvSpPr>
+        <p:spPr>
+          <a:xfrm>
+            <a:off x="777240" y="2551176"/>
+            <a:ext cx="7589520" cy="2066544"/>
           </a:xfrm>
           <a:prstGeom prst="rect">
             <a:avLst/>
@@ -14711,7 +15063,7 @@
       </p:sp>
       <p:sp>
         <p:nvSpPr>
-          <p:cNvPr id="15" name="Text 13"/>
+          <p:cNvPr id="18" name="Text 16"/>
           <p:cNvSpPr/>
           <p:nvPr/>
         </p:nvSpPr>
@@ -15333,7 +15685,7 @@
                 <a:ea typeface="Calibri" pitchFamily="34" charset="-122"/>
                 <a:cs typeface="Calibri" pitchFamily="34" charset="-120"/>
               </a:rPr>
-              <a:t>① 데이터 정의어  ② 데이터 조작어  ③ 데이터 제어어  ④ 데이터 관리어</a:t>
+              <a:t>① 데이터 정의어</a:t>
             </a:r>
             <a:endParaRPr lang="en-US" sz="1100" dirty="0"/>
           </a:p>
@@ -15341,13 +15693,150 @@
       </p:sp>
       <p:sp>
         <p:nvSpPr>
-          <p:cNvPr id="9" name="Shape 7"/>
-          <p:cNvSpPr/>
-          <p:nvPr/>
-        </p:nvSpPr>
-        <p:spPr>
-          <a:xfrm>
-            <a:off x="548640" y="1399032"/>
+          <p:cNvPr id="9" name="Text 7"/>
+          <p:cNvSpPr/>
+          <p:nvPr/>
+        </p:nvSpPr>
+        <p:spPr>
+          <a:xfrm>
+            <a:off x="640080" y="1325880"/>
+            <a:ext cx="7863840" cy="256032"/>
+          </a:xfrm>
+          <a:prstGeom prst="rect">
+            <a:avLst/>
+          </a:prstGeom>
+          <a:noFill/>
+          <a:ln/>
+        </p:spPr>
+        <p:txBody>
+          <a:bodyPr wrap="square" rtlCol="0" anchor="ctr"/>
+          <a:lstStyle/>
+          <a:p>
+            <a:pPr indent="0" marL="0">
+              <a:buNone/>
+            </a:pPr>
+            <a:r>
+              <a:rPr lang="en-US" sz="1100" dirty="0">
+                <a:solidFill>
+                  <a:srgbClr val="64748B"/>
+                </a:solidFill>
+                <a:latin typeface="Calibri" pitchFamily="34" charset="0"/>
+                <a:ea typeface="Calibri" pitchFamily="34" charset="-122"/>
+                <a:cs typeface="Calibri" pitchFamily="34" charset="-120"/>
+              </a:rPr>
+              <a:t>② 데이터 조작어</a:t>
+            </a:r>
+            <a:endParaRPr lang="en-US" sz="1100" dirty="0"/>
+          </a:p>
+        </p:txBody>
+      </p:sp>
+      <p:sp>
+        <p:nvSpPr>
+          <p:cNvPr id="10" name="Shape 8"/>
+          <p:cNvSpPr/>
+          <p:nvPr/>
+        </p:nvSpPr>
+        <p:spPr>
+          <a:xfrm>
+            <a:off x="502920" y="1581912"/>
+            <a:ext cx="8138160" cy="256032"/>
+          </a:xfrm>
+          <a:prstGeom prst="rect">
+            <a:avLst/>
+          </a:prstGeom>
+          <a:solidFill>
+            <a:srgbClr val="FEE2E2"/>
+          </a:solidFill>
+          <a:ln/>
+        </p:spPr>
+      </p:sp>
+      <p:sp>
+        <p:nvSpPr>
+          <p:cNvPr id="11" name="Text 9"/>
+          <p:cNvSpPr/>
+          <p:nvPr/>
+        </p:nvSpPr>
+        <p:spPr>
+          <a:xfrm>
+            <a:off x="640080" y="1581912"/>
+            <a:ext cx="7863840" cy="256032"/>
+          </a:xfrm>
+          <a:prstGeom prst="rect">
+            <a:avLst/>
+          </a:prstGeom>
+          <a:noFill/>
+          <a:ln/>
+        </p:spPr>
+        <p:txBody>
+          <a:bodyPr wrap="square" rtlCol="0" anchor="ctr"/>
+          <a:lstStyle/>
+          <a:p>
+            <a:pPr indent="0" marL="0">
+              <a:buNone/>
+            </a:pPr>
+            <a:r>
+              <a:rPr lang="en-US" sz="1100" b="1" dirty="0">
+                <a:solidFill>
+                  <a:srgbClr val="EF4444"/>
+                </a:solidFill>
+                <a:latin typeface="Calibri" pitchFamily="34" charset="0"/>
+                <a:ea typeface="Calibri" pitchFamily="34" charset="-122"/>
+                <a:cs typeface="Calibri" pitchFamily="34" charset="-120"/>
+              </a:rPr>
+              <a:t>③ 데이터 제어어</a:t>
+            </a:r>
+            <a:endParaRPr lang="en-US" sz="1100" dirty="0"/>
+          </a:p>
+        </p:txBody>
+      </p:sp>
+      <p:sp>
+        <p:nvSpPr>
+          <p:cNvPr id="12" name="Text 10"/>
+          <p:cNvSpPr/>
+          <p:nvPr/>
+        </p:nvSpPr>
+        <p:spPr>
+          <a:xfrm>
+            <a:off x="640080" y="1837944"/>
+            <a:ext cx="7863840" cy="256032"/>
+          </a:xfrm>
+          <a:prstGeom prst="rect">
+            <a:avLst/>
+          </a:prstGeom>
+          <a:noFill/>
+          <a:ln/>
+        </p:spPr>
+        <p:txBody>
+          <a:bodyPr wrap="square" rtlCol="0" anchor="ctr"/>
+          <a:lstStyle/>
+          <a:p>
+            <a:pPr indent="0" marL="0">
+              <a:buNone/>
+            </a:pPr>
+            <a:r>
+              <a:rPr lang="en-US" sz="1100" dirty="0">
+                <a:solidFill>
+                  <a:srgbClr val="64748B"/>
+                </a:solidFill>
+                <a:latin typeface="Calibri" pitchFamily="34" charset="0"/>
+                <a:ea typeface="Calibri" pitchFamily="34" charset="-122"/>
+                <a:cs typeface="Calibri" pitchFamily="34" charset="-120"/>
+              </a:rPr>
+              <a:t>④ 데이터 관리어</a:t>
+            </a:r>
+            <a:endParaRPr lang="en-US" sz="1100" dirty="0"/>
+          </a:p>
+        </p:txBody>
+      </p:sp>
+      <p:sp>
+        <p:nvSpPr>
+          <p:cNvPr id="13" name="Shape 11"/>
+          <p:cNvSpPr/>
+          <p:nvPr/>
+        </p:nvSpPr>
+        <p:spPr>
+          <a:xfrm>
+            <a:off x="548640" y="2167128"/>
             <a:ext cx="8046720" cy="10973"/>
           </a:xfrm>
           <a:prstGeom prst="rect">
@@ -15361,14 +15850,14 @@
       </p:sp>
       <p:sp>
         <p:nvSpPr>
-          <p:cNvPr id="10" name="Shape 8"/>
-          <p:cNvSpPr/>
-          <p:nvPr/>
-        </p:nvSpPr>
-        <p:spPr>
-          <a:xfrm>
-            <a:off x="548640" y="1508760"/>
-            <a:ext cx="8046720" cy="3200400"/>
+          <p:cNvPr id="14" name="Shape 12"/>
+          <p:cNvSpPr/>
+          <p:nvPr/>
+        </p:nvSpPr>
+        <p:spPr>
+          <a:xfrm>
+            <a:off x="548640" y="2276856"/>
+            <a:ext cx="8046720" cy="2432304"/>
           </a:xfrm>
           <a:prstGeom prst="rect">
             <a:avLst/>
@@ -15388,14 +15877,14 @@
       </p:sp>
       <p:sp>
         <p:nvSpPr>
-          <p:cNvPr id="11" name="Shape 9"/>
-          <p:cNvSpPr/>
-          <p:nvPr/>
-        </p:nvSpPr>
-        <p:spPr>
-          <a:xfrm>
-            <a:off x="548640" y="1508760"/>
-            <a:ext cx="54864" cy="3200400"/>
+          <p:cNvPr id="15" name="Shape 13"/>
+          <p:cNvSpPr/>
+          <p:nvPr/>
+        </p:nvSpPr>
+        <p:spPr>
+          <a:xfrm>
+            <a:off x="548640" y="2276856"/>
+            <a:ext cx="54864" cy="2432304"/>
           </a:xfrm>
           <a:prstGeom prst="rect">
             <a:avLst/>
@@ -15408,13 +15897,13 @@
       </p:sp>
       <p:sp>
         <p:nvSpPr>
-          <p:cNvPr id="12" name="Text 10"/>
-          <p:cNvSpPr/>
-          <p:nvPr/>
-        </p:nvSpPr>
-        <p:spPr>
-          <a:xfrm>
-            <a:off x="777240" y="1554480"/>
+          <p:cNvPr id="16" name="Text 14"/>
+          <p:cNvSpPr/>
+          <p:nvPr/>
+        </p:nvSpPr>
+        <p:spPr>
+          <a:xfrm>
+            <a:off x="777240" y="2322576"/>
             <a:ext cx="914400" cy="228600"/>
           </a:xfrm>
           <a:prstGeom prst="rect">
@@ -15447,14 +15936,14 @@
       </p:sp>
       <p:sp>
         <p:nvSpPr>
-          <p:cNvPr id="13" name="Text 11"/>
-          <p:cNvSpPr/>
-          <p:nvPr/>
-        </p:nvSpPr>
-        <p:spPr>
-          <a:xfrm>
-            <a:off x="777240" y="1783080"/>
-            <a:ext cx="7589520" cy="2834640"/>
+          <p:cNvPr id="17" name="Text 15"/>
+          <p:cNvSpPr/>
+          <p:nvPr/>
+        </p:nvSpPr>
+        <p:spPr>
+          <a:xfrm>
+            <a:off x="777240" y="2551176"/>
+            <a:ext cx="7589520" cy="2066544"/>
           </a:xfrm>
           <a:prstGeom prst="rect">
             <a:avLst/>
@@ -15489,7 +15978,7 @@
       </p:sp>
       <p:sp>
         <p:nvSpPr>
-          <p:cNvPr id="14" name="Text 12"/>
+          <p:cNvPr id="18" name="Text 16"/>
           <p:cNvSpPr/>
           <p:nvPr/>
         </p:nvSpPr>
@@ -25710,7 +26199,7 @@
                 <a:ea typeface="Calibri" pitchFamily="34" charset="-122"/>
                 <a:cs typeface="Calibri" pitchFamily="34" charset="-120"/>
               </a:rPr>
-              <a:t>① 외부 스키마  ② 개념 스키마  ③ 내부 스키마  ④ 슈퍼 스키마</a:t>
+              <a:t>① 외부 스키마</a:t>
             </a:r>
             <a:endParaRPr lang="en-US" sz="1100" dirty="0"/>
           </a:p>
@@ -25718,13 +26207,150 @@
       </p:sp>
       <p:sp>
         <p:nvSpPr>
-          <p:cNvPr id="10" name="Shape 8"/>
-          <p:cNvSpPr/>
-          <p:nvPr/>
-        </p:nvSpPr>
-        <p:spPr>
-          <a:xfrm>
-            <a:off x="548640" y="1655064"/>
+          <p:cNvPr id="10" name="Text 8"/>
+          <p:cNvSpPr/>
+          <p:nvPr/>
+        </p:nvSpPr>
+        <p:spPr>
+          <a:xfrm>
+            <a:off x="640080" y="1581912"/>
+            <a:ext cx="7863840" cy="256032"/>
+          </a:xfrm>
+          <a:prstGeom prst="rect">
+            <a:avLst/>
+          </a:prstGeom>
+          <a:noFill/>
+          <a:ln/>
+        </p:spPr>
+        <p:txBody>
+          <a:bodyPr wrap="square" rtlCol="0" anchor="ctr"/>
+          <a:lstStyle/>
+          <a:p>
+            <a:pPr indent="0" marL="0">
+              <a:buNone/>
+            </a:pPr>
+            <a:r>
+              <a:rPr lang="en-US" sz="1100" dirty="0">
+                <a:solidFill>
+                  <a:srgbClr val="64748B"/>
+                </a:solidFill>
+                <a:latin typeface="Calibri" pitchFamily="34" charset="0"/>
+                <a:ea typeface="Calibri" pitchFamily="34" charset="-122"/>
+                <a:cs typeface="Calibri" pitchFamily="34" charset="-120"/>
+              </a:rPr>
+              <a:t>② 개념 스키마</a:t>
+            </a:r>
+            <a:endParaRPr lang="en-US" sz="1100" dirty="0"/>
+          </a:p>
+        </p:txBody>
+      </p:sp>
+      <p:sp>
+        <p:nvSpPr>
+          <p:cNvPr id="11" name="Shape 9"/>
+          <p:cNvSpPr/>
+          <p:nvPr/>
+        </p:nvSpPr>
+        <p:spPr>
+          <a:xfrm>
+            <a:off x="502920" y="1837944"/>
+            <a:ext cx="8138160" cy="256032"/>
+          </a:xfrm>
+          <a:prstGeom prst="rect">
+            <a:avLst/>
+          </a:prstGeom>
+          <a:solidFill>
+            <a:srgbClr val="FEE2E2"/>
+          </a:solidFill>
+          <a:ln/>
+        </p:spPr>
+      </p:sp>
+      <p:sp>
+        <p:nvSpPr>
+          <p:cNvPr id="12" name="Text 10"/>
+          <p:cNvSpPr/>
+          <p:nvPr/>
+        </p:nvSpPr>
+        <p:spPr>
+          <a:xfrm>
+            <a:off x="640080" y="1837944"/>
+            <a:ext cx="7863840" cy="256032"/>
+          </a:xfrm>
+          <a:prstGeom prst="rect">
+            <a:avLst/>
+          </a:prstGeom>
+          <a:noFill/>
+          <a:ln/>
+        </p:spPr>
+        <p:txBody>
+          <a:bodyPr wrap="square" rtlCol="0" anchor="ctr"/>
+          <a:lstStyle/>
+          <a:p>
+            <a:pPr indent="0" marL="0">
+              <a:buNone/>
+            </a:pPr>
+            <a:r>
+              <a:rPr lang="en-US" sz="1100" b="1" dirty="0">
+                <a:solidFill>
+                  <a:srgbClr val="EF4444"/>
+                </a:solidFill>
+                <a:latin typeface="Calibri" pitchFamily="34" charset="0"/>
+                <a:ea typeface="Calibri" pitchFamily="34" charset="-122"/>
+                <a:cs typeface="Calibri" pitchFamily="34" charset="-120"/>
+              </a:rPr>
+              <a:t>③ 내부 스키마</a:t>
+            </a:r>
+            <a:endParaRPr lang="en-US" sz="1100" dirty="0"/>
+          </a:p>
+        </p:txBody>
+      </p:sp>
+      <p:sp>
+        <p:nvSpPr>
+          <p:cNvPr id="13" name="Text 11"/>
+          <p:cNvSpPr/>
+          <p:nvPr/>
+        </p:nvSpPr>
+        <p:spPr>
+          <a:xfrm>
+            <a:off x="640080" y="2093976"/>
+            <a:ext cx="7863840" cy="256032"/>
+          </a:xfrm>
+          <a:prstGeom prst="rect">
+            <a:avLst/>
+          </a:prstGeom>
+          <a:noFill/>
+          <a:ln/>
+        </p:spPr>
+        <p:txBody>
+          <a:bodyPr wrap="square" rtlCol="0" anchor="ctr"/>
+          <a:lstStyle/>
+          <a:p>
+            <a:pPr indent="0" marL="0">
+              <a:buNone/>
+            </a:pPr>
+            <a:r>
+              <a:rPr lang="en-US" sz="1100" dirty="0">
+                <a:solidFill>
+                  <a:srgbClr val="64748B"/>
+                </a:solidFill>
+                <a:latin typeface="Calibri" pitchFamily="34" charset="0"/>
+                <a:ea typeface="Calibri" pitchFamily="34" charset="-122"/>
+                <a:cs typeface="Calibri" pitchFamily="34" charset="-120"/>
+              </a:rPr>
+              <a:t>④ 슈퍼 스키마</a:t>
+            </a:r>
+            <a:endParaRPr lang="en-US" sz="1100" dirty="0"/>
+          </a:p>
+        </p:txBody>
+      </p:sp>
+      <p:sp>
+        <p:nvSpPr>
+          <p:cNvPr id="14" name="Shape 12"/>
+          <p:cNvSpPr/>
+          <p:nvPr/>
+        </p:nvSpPr>
+        <p:spPr>
+          <a:xfrm>
+            <a:off x="548640" y="2423160"/>
             <a:ext cx="8046720" cy="10973"/>
           </a:xfrm>
           <a:prstGeom prst="rect">
@@ -25738,14 +26364,14 @@
       </p:sp>
       <p:sp>
         <p:nvSpPr>
-          <p:cNvPr id="11" name="Shape 9"/>
-          <p:cNvSpPr/>
-          <p:nvPr/>
-        </p:nvSpPr>
-        <p:spPr>
-          <a:xfrm>
-            <a:off x="548640" y="1764792"/>
-            <a:ext cx="8046720" cy="2944368"/>
+          <p:cNvPr id="15" name="Shape 13"/>
+          <p:cNvSpPr/>
+          <p:nvPr/>
+        </p:nvSpPr>
+        <p:spPr>
+          <a:xfrm>
+            <a:off x="548640" y="2532888"/>
+            <a:ext cx="8046720" cy="2176272"/>
           </a:xfrm>
           <a:prstGeom prst="rect">
             <a:avLst/>
@@ -25765,14 +26391,14 @@
       </p:sp>
       <p:sp>
         <p:nvSpPr>
-          <p:cNvPr id="12" name="Shape 10"/>
-          <p:cNvSpPr/>
-          <p:nvPr/>
-        </p:nvSpPr>
-        <p:spPr>
-          <a:xfrm>
-            <a:off x="548640" y="1764792"/>
-            <a:ext cx="54864" cy="2944368"/>
+          <p:cNvPr id="16" name="Shape 14"/>
+          <p:cNvSpPr/>
+          <p:nvPr/>
+        </p:nvSpPr>
+        <p:spPr>
+          <a:xfrm>
+            <a:off x="548640" y="2532888"/>
+            <a:ext cx="54864" cy="2176272"/>
           </a:xfrm>
           <a:prstGeom prst="rect">
             <a:avLst/>
@@ -25785,13 +26411,13 @@
       </p:sp>
       <p:sp>
         <p:nvSpPr>
-          <p:cNvPr id="13" name="Text 11"/>
-          <p:cNvSpPr/>
-          <p:nvPr/>
-        </p:nvSpPr>
-        <p:spPr>
-          <a:xfrm>
-            <a:off x="777240" y="1810512"/>
+          <p:cNvPr id="17" name="Text 15"/>
+          <p:cNvSpPr/>
+          <p:nvPr/>
+        </p:nvSpPr>
+        <p:spPr>
+          <a:xfrm>
+            <a:off x="777240" y="2578608"/>
             <a:ext cx="914400" cy="228600"/>
           </a:xfrm>
           <a:prstGeom prst="rect">
@@ -25824,14 +26450,14 @@
       </p:sp>
       <p:sp>
         <p:nvSpPr>
-          <p:cNvPr id="14" name="Text 12"/>
-          <p:cNvSpPr/>
-          <p:nvPr/>
-        </p:nvSpPr>
-        <p:spPr>
-          <a:xfrm>
-            <a:off x="777240" y="2039112"/>
-            <a:ext cx="7589520" cy="2578608"/>
+          <p:cNvPr id="18" name="Text 16"/>
+          <p:cNvSpPr/>
+          <p:nvPr/>
+        </p:nvSpPr>
+        <p:spPr>
+          <a:xfrm>
+            <a:off x="777240" y="2807208"/>
+            <a:ext cx="7589520" cy="1810512"/>
           </a:xfrm>
           <a:prstGeom prst="rect">
             <a:avLst/>
@@ -25866,7 +26492,7 @@
       </p:sp>
       <p:sp>
         <p:nvSpPr>
-          <p:cNvPr id="15" name="Text 13"/>
+          <p:cNvPr id="19" name="Text 17"/>
           <p:cNvSpPr/>
           <p:nvPr/>
         </p:nvSpPr>
@@ -29131,7 +29757,7 @@
                 <a:ea typeface="Calibri" pitchFamily="34" charset="-122"/>
                 <a:cs typeface="Calibri" pitchFamily="34" charset="-120"/>
               </a:rPr>
-              <a:t>① 외부 스키마  ② 개념 스키마  ③ 내부 스키마  ④ 슈퍼 스키마</a:t>
+              <a:t>① 외부 스키마</a:t>
             </a:r>
             <a:endParaRPr lang="en-US" sz="1100" dirty="0"/>
           </a:p>
@@ -29139,13 +29765,130 @@
       </p:sp>
       <p:sp>
         <p:nvSpPr>
-          <p:cNvPr id="11" name="Shape 9"/>
-          <p:cNvSpPr/>
-          <p:nvPr/>
-        </p:nvSpPr>
-        <p:spPr>
-          <a:xfrm>
-            <a:off x="548640" y="1655064"/>
+          <p:cNvPr id="11" name="Text 9"/>
+          <p:cNvSpPr/>
+          <p:nvPr/>
+        </p:nvSpPr>
+        <p:spPr>
+          <a:xfrm>
+            <a:off x="640080" y="1581912"/>
+            <a:ext cx="7863840" cy="256032"/>
+          </a:xfrm>
+          <a:prstGeom prst="rect">
+            <a:avLst/>
+          </a:prstGeom>
+          <a:noFill/>
+          <a:ln/>
+        </p:spPr>
+        <p:txBody>
+          <a:bodyPr wrap="square" rtlCol="0" anchor="ctr"/>
+          <a:lstStyle/>
+          <a:p>
+            <a:pPr indent="0" marL="0">
+              <a:buNone/>
+            </a:pPr>
+            <a:r>
+              <a:rPr lang="en-US" sz="1100" dirty="0">
+                <a:solidFill>
+                  <a:srgbClr val="64748B"/>
+                </a:solidFill>
+                <a:latin typeface="Calibri" pitchFamily="34" charset="0"/>
+                <a:ea typeface="Calibri" pitchFamily="34" charset="-122"/>
+                <a:cs typeface="Calibri" pitchFamily="34" charset="-120"/>
+              </a:rPr>
+              <a:t>② 개념 스키마</a:t>
+            </a:r>
+            <a:endParaRPr lang="en-US" sz="1100" dirty="0"/>
+          </a:p>
+        </p:txBody>
+      </p:sp>
+      <p:sp>
+        <p:nvSpPr>
+          <p:cNvPr id="12" name="Text 10"/>
+          <p:cNvSpPr/>
+          <p:nvPr/>
+        </p:nvSpPr>
+        <p:spPr>
+          <a:xfrm>
+            <a:off x="640080" y="1837944"/>
+            <a:ext cx="7863840" cy="256032"/>
+          </a:xfrm>
+          <a:prstGeom prst="rect">
+            <a:avLst/>
+          </a:prstGeom>
+          <a:noFill/>
+          <a:ln/>
+        </p:spPr>
+        <p:txBody>
+          <a:bodyPr wrap="square" rtlCol="0" anchor="ctr"/>
+          <a:lstStyle/>
+          <a:p>
+            <a:pPr indent="0" marL="0">
+              <a:buNone/>
+            </a:pPr>
+            <a:r>
+              <a:rPr lang="en-US" sz="1100" dirty="0">
+                <a:solidFill>
+                  <a:srgbClr val="64748B"/>
+                </a:solidFill>
+                <a:latin typeface="Calibri" pitchFamily="34" charset="0"/>
+                <a:ea typeface="Calibri" pitchFamily="34" charset="-122"/>
+                <a:cs typeface="Calibri" pitchFamily="34" charset="-120"/>
+              </a:rPr>
+              <a:t>③ 내부 스키마</a:t>
+            </a:r>
+            <a:endParaRPr lang="en-US" sz="1100" dirty="0"/>
+          </a:p>
+        </p:txBody>
+      </p:sp>
+      <p:sp>
+        <p:nvSpPr>
+          <p:cNvPr id="13" name="Text 11"/>
+          <p:cNvSpPr/>
+          <p:nvPr/>
+        </p:nvSpPr>
+        <p:spPr>
+          <a:xfrm>
+            <a:off x="640080" y="2093976"/>
+            <a:ext cx="7863840" cy="256032"/>
+          </a:xfrm>
+          <a:prstGeom prst="rect">
+            <a:avLst/>
+          </a:prstGeom>
+          <a:noFill/>
+          <a:ln/>
+        </p:spPr>
+        <p:txBody>
+          <a:bodyPr wrap="square" rtlCol="0" anchor="ctr"/>
+          <a:lstStyle/>
+          <a:p>
+            <a:pPr indent="0" marL="0">
+              <a:buNone/>
+            </a:pPr>
+            <a:r>
+              <a:rPr lang="en-US" sz="1100" dirty="0">
+                <a:solidFill>
+                  <a:srgbClr val="64748B"/>
+                </a:solidFill>
+                <a:latin typeface="Calibri" pitchFamily="34" charset="0"/>
+                <a:ea typeface="Calibri" pitchFamily="34" charset="-122"/>
+                <a:cs typeface="Calibri" pitchFamily="34" charset="-120"/>
+              </a:rPr>
+              <a:t>④ 슈퍼 스키마</a:t>
+            </a:r>
+            <a:endParaRPr lang="en-US" sz="1100" dirty="0"/>
+          </a:p>
+        </p:txBody>
+      </p:sp>
+      <p:sp>
+        <p:nvSpPr>
+          <p:cNvPr id="14" name="Shape 12"/>
+          <p:cNvSpPr/>
+          <p:nvPr/>
+        </p:nvSpPr>
+        <p:spPr>
+          <a:xfrm>
+            <a:off x="548640" y="2423160"/>
             <a:ext cx="8046720" cy="10973"/>
           </a:xfrm>
           <a:prstGeom prst="rect">
@@ -29159,14 +29902,14 @@
       </p:sp>
       <p:sp>
         <p:nvSpPr>
-          <p:cNvPr id="12" name="Shape 10"/>
-          <p:cNvSpPr/>
-          <p:nvPr/>
-        </p:nvSpPr>
-        <p:spPr>
-          <a:xfrm>
-            <a:off x="548640" y="1764792"/>
-            <a:ext cx="8046720" cy="2944368"/>
+          <p:cNvPr id="15" name="Shape 13"/>
+          <p:cNvSpPr/>
+          <p:nvPr/>
+        </p:nvSpPr>
+        <p:spPr>
+          <a:xfrm>
+            <a:off x="548640" y="2532888"/>
+            <a:ext cx="8046720" cy="2176272"/>
           </a:xfrm>
           <a:prstGeom prst="rect">
             <a:avLst/>
@@ -29186,14 +29929,14 @@
       </p:sp>
       <p:sp>
         <p:nvSpPr>
-          <p:cNvPr id="13" name="Shape 11"/>
-          <p:cNvSpPr/>
-          <p:nvPr/>
-        </p:nvSpPr>
-        <p:spPr>
-          <a:xfrm>
-            <a:off x="548640" y="1764792"/>
-            <a:ext cx="54864" cy="2944368"/>
+          <p:cNvPr id="16" name="Shape 14"/>
+          <p:cNvSpPr/>
+          <p:nvPr/>
+        </p:nvSpPr>
+        <p:spPr>
+          <a:xfrm>
+            <a:off x="548640" y="2532888"/>
+            <a:ext cx="54864" cy="2176272"/>
           </a:xfrm>
           <a:prstGeom prst="rect">
             <a:avLst/>
@@ -29206,13 +29949,13 @@
       </p:sp>
       <p:sp>
         <p:nvSpPr>
-          <p:cNvPr id="14" name="Text 12"/>
-          <p:cNvSpPr/>
-          <p:nvPr/>
-        </p:nvSpPr>
-        <p:spPr>
-          <a:xfrm>
-            <a:off x="777240" y="1810512"/>
+          <p:cNvPr id="17" name="Text 15"/>
+          <p:cNvSpPr/>
+          <p:nvPr/>
+        </p:nvSpPr>
+        <p:spPr>
+          <a:xfrm>
+            <a:off x="777240" y="2578608"/>
             <a:ext cx="914400" cy="228600"/>
           </a:xfrm>
           <a:prstGeom prst="rect">
@@ -29245,14 +29988,14 @@
       </p:sp>
       <p:sp>
         <p:nvSpPr>
-          <p:cNvPr id="15" name="Text 13"/>
-          <p:cNvSpPr/>
-          <p:nvPr/>
-        </p:nvSpPr>
-        <p:spPr>
-          <a:xfrm>
-            <a:off x="777240" y="2039112"/>
-            <a:ext cx="7589520" cy="2578608"/>
+          <p:cNvPr id="18" name="Text 16"/>
+          <p:cNvSpPr/>
+          <p:nvPr/>
+        </p:nvSpPr>
+        <p:spPr>
+          <a:xfrm>
+            <a:off x="777240" y="2807208"/>
+            <a:ext cx="7589520" cy="1810512"/>
           </a:xfrm>
           <a:prstGeom prst="rect">
             <a:avLst/>
@@ -29287,7 +30030,7 @@
       </p:sp>
       <p:sp>
         <p:nvSpPr>
-          <p:cNvPr id="16" name="Text 14"/>
+          <p:cNvPr id="19" name="Text 17"/>
           <p:cNvSpPr/>
           <p:nvPr/>
         </p:nvSpPr>

</xml_diff>